<commit_message>
Add rehearsal card; drop stray presenter badge from B3
Rehearsal Card - Who Presents What: one page per speaker with slides,
timing, the message to land, the handoff line, and which backup slide
answers which likely question. Built for this weekend's run-throughs.

Flags the two changes a presenter could get wrong from muscle memory:
slide 6 is "heavily reviewed" not "experienced" (tenure is flat across
quartiles, only review count tracks occupancy), and slide 8 now counts
both halves rather than excluding the overpriced side.

Also removes the PRESENTS badge B3 inherited when it was cloned from
slide 5 - backups are pulled up on demand, not presented.

Co-Authored-By: Claude Opus 5 <noreply@anthropic.com>
</commit_message>
<xml_diff>
--- a/Airbnb Pricing Deck.pptx
+++ b/Airbnb Pricing Deck.pptx
@@ -15608,112 +15608,6 @@
           </a:p>
         </p:txBody>
       </p:sp>
-      <p:sp>
-        <p:nvSpPr>
-          <p:cNvPr id="5" name="Shape 3"/>
-          <p:cNvSpPr/>
-          <p:nvPr/>
-        </p:nvSpPr>
-        <p:spPr>
-          <a:xfrm>
-            <a:off x="9357055" y="475488"/>
-            <a:ext cx="2331720" cy="365760"/>
-          </a:xfrm>
-          <a:prstGeom prst="roundRect">
-            <a:avLst>
-              <a:gd name="adj" fmla="val 50000"/>
-            </a:avLst>
-          </a:prstGeom>
-          <a:solidFill>
-            <a:srgbClr val="F2F3F5"/>
-          </a:solidFill>
-          <a:ln/>
-        </p:spPr>
-        <p:txBody>
-          <a:bodyPr/>
-          <a:lstStyle/>
-          <a:p>
-            <a:endParaRPr lang="en-US"/>
-          </a:p>
-        </p:txBody>
-      </p:sp>
-      <p:sp>
-        <p:nvSpPr>
-          <p:cNvPr id="6" name="Shape 4"/>
-          <p:cNvSpPr/>
-          <p:nvPr/>
-        </p:nvSpPr>
-        <p:spPr>
-          <a:xfrm>
-            <a:off x="9503359" y="585216"/>
-            <a:ext cx="146304" cy="146304"/>
-          </a:xfrm>
-          <a:prstGeom prst="ellipse">
-            <a:avLst/>
-          </a:prstGeom>
-          <a:solidFill>
-            <a:srgbClr val="FF385C"/>
-          </a:solidFill>
-          <a:ln/>
-        </p:spPr>
-        <p:txBody>
-          <a:bodyPr/>
-          <a:lstStyle/>
-          <a:p>
-            <a:endParaRPr lang="en-US"/>
-          </a:p>
-        </p:txBody>
-      </p:sp>
-      <p:sp>
-        <p:nvSpPr>
-          <p:cNvPr id="7" name="Text 5"/>
-          <p:cNvSpPr/>
-          <p:nvPr/>
-        </p:nvSpPr>
-        <p:spPr>
-          <a:xfrm>
-            <a:off x="9667951" y="475488"/>
-            <a:ext cx="1965960" cy="365760"/>
-          </a:xfrm>
-          <a:prstGeom prst="rect">
-            <a:avLst/>
-          </a:prstGeom>
-          <a:noFill/>
-          <a:ln/>
-        </p:spPr>
-        <p:txBody>
-          <a:bodyPr wrap="square" lIns="0" tIns="0" rIns="0" bIns="0" rtlCol="0" anchor="ctr"/>
-          <a:lstStyle/>
-          <a:p>
-            <a:pPr marL="0" indent="0">
-              <a:buNone/>
-            </a:pPr>
-            <a:r>
-              <a:rPr lang="en-US" sz="950" b="1" kern="0" spc="100" dirty="0">
-                <a:solidFill>
-                  <a:srgbClr val="9AA0A6"/>
-                </a:solidFill>
-                <a:latin typeface="Poppins" pitchFamily="34" charset="0"/>
-                <a:ea typeface="Poppins" pitchFamily="34" charset="-122"/>
-                <a:cs typeface="Poppins" pitchFamily="34" charset="-120"/>
-              </a:rPr>
-              <a:t>PRESENTS  </a:t>
-            </a:r>
-            <a:r>
-              <a:rPr lang="en-US" sz="950" b="1" dirty="0">
-                <a:solidFill>
-                  <a:srgbClr val="222222"/>
-                </a:solidFill>
-                <a:latin typeface="Poppins" pitchFamily="34" charset="0"/>
-                <a:ea typeface="Poppins" pitchFamily="34" charset="-122"/>
-                <a:cs typeface="Poppins" pitchFamily="34" charset="-120"/>
-              </a:rPr>
-              <a:t>Rachael</a:t>
-            </a:r>
-            <a:endParaRPr lang="en-US" sz="950" dirty="0"/>
-          </a:p>
-        </p:txBody>
-      </p:sp>
       <p:pic>
         <p:nvPicPr>
           <p:cNvPr id="8" name="Image 0" descr="/sessions/dreamy-trusting-noether/mnt/outputs/build/assets/cornell_dark.png"/>

</xml_diff>

<commit_message>
Rebuild Executive Summary (slide 2) to lead with the numbers
The rubric asks for headline figures in the executive summary. Slide 2
had none - it carried problem/answer blocks plus a Predict/Explain/Act
triptych that duplicated slide 7. This was flagged in the v1 script
review and never fixed.

Slide 2 now states problem, solution and payoff in that order:
  - headline: "$1.17M a year, for a $65K build"
  - three stat blocks replacing the triptych: $1.17M / ~3 months / $65K
  - closing line positions this as building on Smart Pricing

Script slide 2 narration rewritten to match - it had no headline figures
either. Planning Notes deck-defect table updated: every listed defect is
now resolved, backup slides renamed B1-B5, slide count corrected to 20.

Co-Authored-By: Claude Opus 5 <noreply@anthropic.com>
</commit_message>
<xml_diff>
--- a/Airbnb Pricing Deck.pptx
+++ b/Airbnb Pricing Deck.pptx
@@ -17658,7 +17658,7 @@
                 <a:ea typeface="Poppins" pitchFamily="34" charset="-122"/>
                 <a:cs typeface="Poppins" pitchFamily="34" charset="-120"/>
               </a:rPr>
-              <a:t>The pricing problem — and our answer</a:t>
+              <a:t>$1.17M a year, for a $65K build</a:t>
             </a:r>
             <a:endParaRPr lang="en-US" sz="2900" dirty="0"/>
           </a:p>
@@ -17700,7 +17700,7 @@
                 <a:ea typeface="Poppins" pitchFamily="34" charset="-122"/>
                 <a:cs typeface="Poppins" pitchFamily="34" charset="-120"/>
               </a:rPr>
-              <a:t>Hosts want to maximize revenue, but pricing is hard and today's help is a black box.</a:t>
+              <a:t>Half of NYC's listings are priced wrong. We show hosts by how much and why — and Airbnb earns on every correction.</a:t>
             </a:r>
             <a:endParaRPr lang="en-US" sz="1450" dirty="0"/>
           </a:p>
@@ -18096,7 +18096,7 @@
                 <a:ea typeface="Poppins" pitchFamily="34" charset="-122"/>
                 <a:cs typeface="Poppins" pitchFamily="34" charset="-120"/>
               </a:rPr>
-              <a:t>Smart Pricing hands hosts a number with no “why” — no comparable listings, no drivers, no room to explore. So hosts either ignore it or follow it blindly.</a:t>
+              <a:t>Smart Pricing hands hosts a number with no reasoning — no comparables, no drivers, nothing to explore. So hosts ignore it, or follow it blindly.</a:t>
             </a:r>
             <a:endParaRPr lang="en-US" sz="1200" dirty="0"/>
           </a:p>
@@ -18269,7 +18269,7 @@
                 <a:ea typeface="Poppins" pitchFamily="34" charset="-122"/>
                 <a:cs typeface="Poppins" pitchFamily="34" charset="-120"/>
               </a:rPr>
-              <a:t>A platform that pairs a machine-learning fair price with comparable listings and an interactive dashboard — so hosts understand and trust the recommendation, not just receive it.</a:t>
+              <a:t>A fair price a host can actually interrogate: the comparable listings behind it, the amenity gaps against high performers, and a slider to test any price.</a:t>
             </a:r>
             <a:endParaRPr lang="en-US" sz="1200" dirty="0"/>
           </a:p>
@@ -18318,65 +18318,14 @@
       </p:sp>
       <p:sp>
         <p:nvSpPr>
-          <p:cNvPr id="23" name="Shape 17"/>
-          <p:cNvSpPr/>
-          <p:nvPr/>
-        </p:nvSpPr>
-        <p:spPr>
-          <a:xfrm>
-            <a:off x="740664" y="4434840"/>
-            <a:ext cx="548640" cy="548640"/>
-          </a:xfrm>
-          <a:prstGeom prst="ellipse">
-            <a:avLst/>
-          </a:prstGeom>
-          <a:solidFill>
-            <a:srgbClr val="FFEEF2"/>
-          </a:solidFill>
-          <a:ln/>
-        </p:spPr>
-        <p:txBody>
-          <a:bodyPr/>
-          <a:lstStyle/>
-          <a:p>
-            <a:endParaRPr lang="en-US"/>
-          </a:p>
-        </p:txBody>
-      </p:sp>
-      <p:pic>
-        <p:nvPicPr>
-          <p:cNvPr id="24" name="Image 4" descr="/sessions/dreamy-trusting-noether/mnt/outputs/build/assets/cpu_coral.png"/>
-          <p:cNvPicPr>
-            <a:picLocks noChangeAspect="1"/>
-          </p:cNvPicPr>
-          <p:nvPr/>
-        </p:nvPicPr>
-        <p:blipFill>
-          <a:blip r:embed="rId7"/>
-          <a:stretch>
-            <a:fillRect/>
-          </a:stretch>
-        </p:blipFill>
-        <p:spPr>
-          <a:xfrm>
-            <a:off x="872338" y="4566514"/>
-            <a:ext cx="285293" cy="285293"/>
-          </a:xfrm>
-          <a:prstGeom prst="rect">
-            <a:avLst/>
-          </a:prstGeom>
-        </p:spPr>
-      </p:pic>
-      <p:sp>
-        <p:nvSpPr>
           <p:cNvPr id="25" name="Text 18"/>
           <p:cNvSpPr/>
           <p:nvPr/>
         </p:nvSpPr>
         <p:spPr>
           <a:xfrm>
-            <a:off x="1399032" y="4489704"/>
-            <a:ext cx="2557272" cy="365760"/>
+            <a:off x="758952" y="4462272"/>
+            <a:ext cx="3054096" cy="548640"/>
           </a:xfrm>
           <a:prstGeom prst="rect">
             <a:avLst/>
@@ -18392,15 +18341,15 @@
               <a:buNone/>
             </a:pPr>
             <a:r>
-              <a:rPr lang="en-US" sz="1500" b="1" dirty="0">
-                <a:solidFill>
-                  <a:srgbClr val="FF385C"/>
-                </a:solidFill>
-                <a:latin typeface="Poppins" pitchFamily="34" charset="0"/>
-                <a:ea typeface="Poppins" pitchFamily="34" charset="-122"/>
-                <a:cs typeface="Poppins" pitchFamily="34" charset="-120"/>
-              </a:rPr>
-              <a:t>Predict</a:t>
+              <a:rPr lang="en-US" sz="3000" b="1" dirty="0">
+                <a:solidFill>
+                  <a:srgbClr val="222222"/>
+                </a:solidFill>
+                <a:latin typeface="Poppins" pitchFamily="34" charset="0"/>
+                <a:ea typeface="Poppins" pitchFamily="34" charset="-122"/>
+                <a:cs typeface="Poppins" pitchFamily="34" charset="-120"/>
+              </a:rPr>
+              <a:t>$1.17M</a:t>
             </a:r>
             <a:endParaRPr lang="en-US" sz="1500" dirty="0"/>
           </a:p>
@@ -18414,8 +18363,8 @@
         </p:nvSpPr>
         <p:spPr>
           <a:xfrm>
-            <a:off x="758952" y="5038344"/>
-            <a:ext cx="3051048" cy="502920"/>
+            <a:off x="758952" y="5047488"/>
+            <a:ext cx="3054096" cy="548640"/>
           </a:xfrm>
           <a:prstGeom prst="rect">
             <a:avLst/>
@@ -18434,7 +18383,7 @@
               <a:buNone/>
             </a:pPr>
             <a:r>
-              <a:rPr lang="en-US" sz="1100" dirty="0">
+              <a:rPr lang="en-US" sz="1100" dirty="0" b="0">
                 <a:solidFill>
                   <a:srgbClr val="717171"/>
                 </a:solidFill>
@@ -18442,7 +18391,7 @@
                 <a:ea typeface="Poppins" pitchFamily="34" charset="-122"/>
                 <a:cs typeface="Poppins" pitchFamily="34" charset="-120"/>
               </a:rPr>
-              <a:t>A calibrated fair nightly price from a gradient-boosting model.</a:t>
+              <a:t>a year in new Airbnb fees, from the NYC pilot alone</a:t>
             </a:r>
             <a:endParaRPr lang="en-US" sz="1100" dirty="0"/>
           </a:p>
@@ -18491,65 +18440,14 @@
       </p:sp>
       <p:sp>
         <p:nvSpPr>
-          <p:cNvPr id="28" name="Shape 21"/>
-          <p:cNvSpPr/>
-          <p:nvPr/>
-        </p:nvSpPr>
-        <p:spPr>
-          <a:xfrm>
-            <a:off x="4550664" y="4434840"/>
-            <a:ext cx="548640" cy="548640"/>
-          </a:xfrm>
-          <a:prstGeom prst="ellipse">
-            <a:avLst/>
-          </a:prstGeom>
-          <a:solidFill>
-            <a:srgbClr val="E6F6F4"/>
-          </a:solidFill>
-          <a:ln/>
-        </p:spPr>
-        <p:txBody>
-          <a:bodyPr/>
-          <a:lstStyle/>
-          <a:p>
-            <a:endParaRPr lang="en-US"/>
-          </a:p>
-        </p:txBody>
-      </p:sp>
-      <p:pic>
-        <p:nvPicPr>
-          <p:cNvPr id="29" name="Image 5" descr="/sessions/dreamy-trusting-noether/mnt/outputs/build/assets/search_teal.png"/>
-          <p:cNvPicPr>
-            <a:picLocks noChangeAspect="1"/>
-          </p:cNvPicPr>
-          <p:nvPr/>
-        </p:nvPicPr>
-        <p:blipFill>
-          <a:blip r:embed="rId8"/>
-          <a:stretch>
-            <a:fillRect/>
-          </a:stretch>
-        </p:blipFill>
-        <p:spPr>
-          <a:xfrm>
-            <a:off x="4682338" y="4566514"/>
-            <a:ext cx="285293" cy="285293"/>
-          </a:xfrm>
-          <a:prstGeom prst="rect">
-            <a:avLst/>
-          </a:prstGeom>
-        </p:spPr>
-      </p:pic>
-      <p:sp>
-        <p:nvSpPr>
           <p:cNvPr id="30" name="Text 22"/>
           <p:cNvSpPr/>
           <p:nvPr/>
         </p:nvSpPr>
         <p:spPr>
           <a:xfrm>
-            <a:off x="5209032" y="4489704"/>
-            <a:ext cx="2557272" cy="365760"/>
+            <a:off x="4572000" y="4462272"/>
+            <a:ext cx="3054096" cy="548640"/>
           </a:xfrm>
           <a:prstGeom prst="rect">
             <a:avLst/>
@@ -18565,15 +18463,15 @@
               <a:buNone/>
             </a:pPr>
             <a:r>
-              <a:rPr lang="en-US" sz="1500" b="1" dirty="0">
-                <a:solidFill>
-                  <a:srgbClr val="007A73"/>
-                </a:solidFill>
-                <a:latin typeface="Poppins" pitchFamily="34" charset="0"/>
-                <a:ea typeface="Poppins" pitchFamily="34" charset="-122"/>
-                <a:cs typeface="Poppins" pitchFamily="34" charset="-120"/>
-              </a:rPr>
-              <a:t>Explain</a:t>
+              <a:rPr lang="en-US" sz="3000" b="1" dirty="0">
+                <a:solidFill>
+                  <a:srgbClr val="222222"/>
+                </a:solidFill>
+                <a:latin typeface="Poppins" pitchFamily="34" charset="0"/>
+                <a:ea typeface="Poppins" pitchFamily="34" charset="-122"/>
+                <a:cs typeface="Poppins" pitchFamily="34" charset="-120"/>
+              </a:rPr>
+              <a:t>~3 months</a:t>
             </a:r>
             <a:endParaRPr lang="en-US" sz="1500" dirty="0"/>
           </a:p>
@@ -18587,8 +18485,8 @@
         </p:nvSpPr>
         <p:spPr>
           <a:xfrm>
-            <a:off x="4568952" y="5038344"/>
-            <a:ext cx="3051048" cy="502920"/>
+            <a:off x="4572000" y="5047488"/>
+            <a:ext cx="3054096" cy="548640"/>
           </a:xfrm>
           <a:prstGeom prst="rect">
             <a:avLst/>
@@ -18607,7 +18505,7 @@
               <a:buNone/>
             </a:pPr>
             <a:r>
-              <a:rPr lang="en-US" sz="1100" dirty="0">
+              <a:rPr lang="en-US" sz="1100" dirty="0" b="0">
                 <a:solidFill>
                   <a:srgbClr val="717171"/>
                 </a:solidFill>
@@ -18615,7 +18513,7 @@
                 <a:ea typeface="Poppins" pitchFamily="34" charset="-122"/>
                 <a:cs typeface="Poppins" pitchFamily="34" charset="-120"/>
               </a:rPr>
-              <a:t>The comparable listings and features behind that number.</a:t>
+              <a:t>to pay the build back, at a realistic 35% adoption</a:t>
             </a:r>
             <a:endParaRPr lang="en-US" sz="1100" dirty="0"/>
           </a:p>
@@ -18664,65 +18562,14 @@
       </p:sp>
       <p:sp>
         <p:nvSpPr>
-          <p:cNvPr id="33" name="Shape 25"/>
-          <p:cNvSpPr/>
-          <p:nvPr/>
-        </p:nvSpPr>
-        <p:spPr>
-          <a:xfrm>
-            <a:off x="8360664" y="4434840"/>
-            <a:ext cx="548640" cy="548640"/>
-          </a:xfrm>
-          <a:prstGeom prst="ellipse">
-            <a:avLst/>
-          </a:prstGeom>
-          <a:solidFill>
-            <a:srgbClr val="FFEEF2"/>
-          </a:solidFill>
-          <a:ln/>
-        </p:spPr>
-        <p:txBody>
-          <a:bodyPr/>
-          <a:lstStyle/>
-          <a:p>
-            <a:endParaRPr lang="en-US"/>
-          </a:p>
-        </p:txBody>
-      </p:sp>
-      <p:pic>
-        <p:nvPicPr>
-          <p:cNvPr id="34" name="Image 6" descr="/sessions/dreamy-trusting-noether/mnt/outputs/build/assets/trend_coral.png"/>
-          <p:cNvPicPr>
-            <a:picLocks noChangeAspect="1"/>
-          </p:cNvPicPr>
-          <p:nvPr/>
-        </p:nvPicPr>
-        <p:blipFill>
-          <a:blip r:embed="rId9"/>
-          <a:stretch>
-            <a:fillRect/>
-          </a:stretch>
-        </p:blipFill>
-        <p:spPr>
-          <a:xfrm>
-            <a:off x="8492338" y="4566514"/>
-            <a:ext cx="285293" cy="285293"/>
-          </a:xfrm>
-          <a:prstGeom prst="rect">
-            <a:avLst/>
-          </a:prstGeom>
-        </p:spPr>
-      </p:pic>
-      <p:sp>
-        <p:nvSpPr>
           <p:cNvPr id="35" name="Text 26"/>
           <p:cNvSpPr/>
           <p:nvPr/>
         </p:nvSpPr>
         <p:spPr>
           <a:xfrm>
-            <a:off x="9019032" y="4489704"/>
-            <a:ext cx="2557272" cy="365760"/>
+            <a:off x="8375904" y="4462272"/>
+            <a:ext cx="3054096" cy="548640"/>
           </a:xfrm>
           <a:prstGeom prst="rect">
             <a:avLst/>
@@ -18738,15 +18585,15 @@
               <a:buNone/>
             </a:pPr>
             <a:r>
-              <a:rPr lang="en-US" sz="1500" b="1" dirty="0">
-                <a:solidFill>
-                  <a:srgbClr val="FF385C"/>
-                </a:solidFill>
-                <a:latin typeface="Poppins" pitchFamily="34" charset="0"/>
-                <a:ea typeface="Poppins" pitchFamily="34" charset="-122"/>
-                <a:cs typeface="Poppins" pitchFamily="34" charset="-120"/>
-              </a:rPr>
-              <a:t>Act</a:t>
+              <a:rPr lang="en-US" sz="3000" b="1" dirty="0">
+                <a:solidFill>
+                  <a:srgbClr val="222222"/>
+                </a:solidFill>
+                <a:latin typeface="Poppins" pitchFamily="34" charset="0"/>
+                <a:ea typeface="Poppins" pitchFamily="34" charset="-122"/>
+                <a:cs typeface="Poppins" pitchFamily="34" charset="-120"/>
+              </a:rPr>
+              <a:t>$65K</a:t>
             </a:r>
             <a:endParaRPr lang="en-US" sz="1500" dirty="0"/>
           </a:p>
@@ -18760,8 +18607,8 @@
         </p:nvSpPr>
         <p:spPr>
           <a:xfrm>
-            <a:off x="8378952" y="5038344"/>
-            <a:ext cx="3051048" cy="502920"/>
+            <a:off x="8375904" y="5047488"/>
+            <a:ext cx="3054096" cy="548640"/>
           </a:xfrm>
           <a:prstGeom prst="rect">
             <a:avLst/>
@@ -18780,7 +18627,7 @@
               <a:buNone/>
             </a:pPr>
             <a:r>
-              <a:rPr lang="en-US" sz="1100" dirty="0">
+              <a:rPr lang="en-US" sz="1100" dirty="0" b="0">
                 <a:solidFill>
                   <a:srgbClr val="717171"/>
                 </a:solidFill>
@@ -18788,7 +18635,7 @@
                 <a:ea typeface="Poppins" pitchFamily="34" charset="-122"/>
                 <a:cs typeface="Poppins" pitchFamily="34" charset="-120"/>
               </a:rPr>
-              <a:t>A what-if view of how price changes affect projected revenue.</a:t>
+              <a:t>one-time build, then $30K a year to run</a:t>
             </a:r>
             <a:endParaRPr lang="en-US" sz="1100" dirty="0"/>
           </a:p>
@@ -18827,7 +18674,7 @@
                 <a:ea typeface="Poppins" pitchFamily="34" charset="-122"/>
                 <a:cs typeface="Poppins" pitchFamily="34" charset="-120"/>
               </a:rPr>
-              <a:t>Our goal isn't to replace Smart Pricing — it's to make pricing recommendations transparent and easy to act on.</a:t>
+              <a:t>Every underpriced night costs the host and Airbnb both. We build on Smart Pricing, not replace it.</a:t>
             </a:r>
             <a:endParaRPr lang="en-US" sz="1250" dirty="0"/>
           </a:p>

</xml_diff>